<commit_message>
feat: minister deck v5 — 6 slides, inline SVG charts, full canvas
Rebuilt from scratch: 6-slide structure (Who We Are, Problem, Solution,
Process, Impact, P&L). Inline SVG replaces Chart.js CDN dependency.
Every slide verified visually before assembly.

Co-Authored-By: Claude Sonnet 4.6 <noreply@anthropic.com>
Claude-Session: https://claude.ai/code/session_018BF5dwEyDtx18mYjzPXKzY
</commit_message>
<xml_diff>
--- a/outputs/Jahizoon_Minister_Presentation.pptx
+++ b/outputs/Jahizoon_Minister_Presentation.pptx
@@ -11,18 +11,6 @@
     <p:sldId id="259" r:id="rId10"/>
     <p:sldId id="260" r:id="rId11"/>
     <p:sldId id="261" r:id="rId12"/>
-    <p:sldId id="262" r:id="rId13"/>
-    <p:sldId id="263" r:id="rId14"/>
-    <p:sldId id="264" r:id="rId15"/>
-    <p:sldId id="265" r:id="rId16"/>
-    <p:sldId id="266" r:id="rId17"/>
-    <p:sldId id="267" r:id="rId18"/>
-    <p:sldId id="268" r:id="rId19"/>
-    <p:sldId id="269" r:id="rId20"/>
-    <p:sldId id="270" r:id="rId21"/>
-    <p:sldId id="271" r:id="rId22"/>
-    <p:sldId id="272" r:id="rId23"/>
-    <p:sldId id="273" r:id="rId24"/>
   </p:sldIdLst>
   <p:sldSz cx="9144000" cy="5143500" type="screen4x3"/>
   <p:notesSz cx="6858000" cy="9144000"/>
@@ -3137,384 +3125,6 @@
 </p:sld>
 </file>
 
-<file path=ppt/slides/slide10.xml><?xml version="1.0" encoding="utf-8"?>
-<p:sld xmlns:a="http://schemas.openxmlformats.org/drawingml/2006/main" xmlns:p="http://schemas.openxmlformats.org/presentationml/2006/main" xmlns:r="http://schemas.openxmlformats.org/officeDocument/2006/relationships">
-  <p:cSld>
-    <p:spTree>
-      <p:nvGrpSpPr>
-        <p:cNvPr id="1" name=""/>
-        <p:cNvGrpSpPr/>
-        <p:nvPr/>
-      </p:nvGrpSpPr>
-      <p:grpSpPr/>
-      <p:pic>
-        <p:nvPicPr>
-          <p:cNvPr id="2" name="Picture 1" descr="10.png"/>
-          <p:cNvPicPr>
-            <a:picLocks noChangeAspect="1"/>
-          </p:cNvPicPr>
-          <p:nvPr/>
-        </p:nvPicPr>
-        <p:blipFill>
-          <a:blip r:embed="rId2"/>
-          <a:stretch>
-            <a:fillRect/>
-          </a:stretch>
-        </p:blipFill>
-        <p:spPr>
-          <a:xfrm>
-            <a:off x="0" y="0"/>
-            <a:ext cx="9144000" cy="5143500"/>
-          </a:xfrm>
-          <a:prstGeom prst="rect">
-            <a:avLst/>
-          </a:prstGeom>
-        </p:spPr>
-      </p:pic>
-    </p:spTree>
-  </p:cSld>
-  <p:clrMapOvr>
-    <a:masterClrMapping/>
-  </p:clrMapOvr>
-</p:sld>
-</file>
-
-<file path=ppt/slides/slide11.xml><?xml version="1.0" encoding="utf-8"?>
-<p:sld xmlns:a="http://schemas.openxmlformats.org/drawingml/2006/main" xmlns:p="http://schemas.openxmlformats.org/presentationml/2006/main" xmlns:r="http://schemas.openxmlformats.org/officeDocument/2006/relationships">
-  <p:cSld>
-    <p:spTree>
-      <p:nvGrpSpPr>
-        <p:cNvPr id="1" name=""/>
-        <p:cNvGrpSpPr/>
-        <p:nvPr/>
-      </p:nvGrpSpPr>
-      <p:grpSpPr/>
-      <p:pic>
-        <p:nvPicPr>
-          <p:cNvPr id="2" name="Picture 1" descr="11.png"/>
-          <p:cNvPicPr>
-            <a:picLocks noChangeAspect="1"/>
-          </p:cNvPicPr>
-          <p:nvPr/>
-        </p:nvPicPr>
-        <p:blipFill>
-          <a:blip r:embed="rId2"/>
-          <a:stretch>
-            <a:fillRect/>
-          </a:stretch>
-        </p:blipFill>
-        <p:spPr>
-          <a:xfrm>
-            <a:off x="0" y="0"/>
-            <a:ext cx="9144000" cy="5143500"/>
-          </a:xfrm>
-          <a:prstGeom prst="rect">
-            <a:avLst/>
-          </a:prstGeom>
-        </p:spPr>
-      </p:pic>
-    </p:spTree>
-  </p:cSld>
-  <p:clrMapOvr>
-    <a:masterClrMapping/>
-  </p:clrMapOvr>
-</p:sld>
-</file>
-
-<file path=ppt/slides/slide12.xml><?xml version="1.0" encoding="utf-8"?>
-<p:sld xmlns:a="http://schemas.openxmlformats.org/drawingml/2006/main" xmlns:p="http://schemas.openxmlformats.org/presentationml/2006/main" xmlns:r="http://schemas.openxmlformats.org/officeDocument/2006/relationships">
-  <p:cSld>
-    <p:spTree>
-      <p:nvGrpSpPr>
-        <p:cNvPr id="1" name=""/>
-        <p:cNvGrpSpPr/>
-        <p:nvPr/>
-      </p:nvGrpSpPr>
-      <p:grpSpPr/>
-      <p:pic>
-        <p:nvPicPr>
-          <p:cNvPr id="2" name="Picture 1" descr="12.png"/>
-          <p:cNvPicPr>
-            <a:picLocks noChangeAspect="1"/>
-          </p:cNvPicPr>
-          <p:nvPr/>
-        </p:nvPicPr>
-        <p:blipFill>
-          <a:blip r:embed="rId2"/>
-          <a:stretch>
-            <a:fillRect/>
-          </a:stretch>
-        </p:blipFill>
-        <p:spPr>
-          <a:xfrm>
-            <a:off x="0" y="0"/>
-            <a:ext cx="9144000" cy="5143500"/>
-          </a:xfrm>
-          <a:prstGeom prst="rect">
-            <a:avLst/>
-          </a:prstGeom>
-        </p:spPr>
-      </p:pic>
-    </p:spTree>
-  </p:cSld>
-  <p:clrMapOvr>
-    <a:masterClrMapping/>
-  </p:clrMapOvr>
-</p:sld>
-</file>
-
-<file path=ppt/slides/slide13.xml><?xml version="1.0" encoding="utf-8"?>
-<p:sld xmlns:a="http://schemas.openxmlformats.org/drawingml/2006/main" xmlns:p="http://schemas.openxmlformats.org/presentationml/2006/main" xmlns:r="http://schemas.openxmlformats.org/officeDocument/2006/relationships">
-  <p:cSld>
-    <p:spTree>
-      <p:nvGrpSpPr>
-        <p:cNvPr id="1" name=""/>
-        <p:cNvGrpSpPr/>
-        <p:nvPr/>
-      </p:nvGrpSpPr>
-      <p:grpSpPr/>
-      <p:pic>
-        <p:nvPicPr>
-          <p:cNvPr id="2" name="Picture 1" descr="13.png"/>
-          <p:cNvPicPr>
-            <a:picLocks noChangeAspect="1"/>
-          </p:cNvPicPr>
-          <p:nvPr/>
-        </p:nvPicPr>
-        <p:blipFill>
-          <a:blip r:embed="rId2"/>
-          <a:stretch>
-            <a:fillRect/>
-          </a:stretch>
-        </p:blipFill>
-        <p:spPr>
-          <a:xfrm>
-            <a:off x="0" y="0"/>
-            <a:ext cx="9144000" cy="5143500"/>
-          </a:xfrm>
-          <a:prstGeom prst="rect">
-            <a:avLst/>
-          </a:prstGeom>
-        </p:spPr>
-      </p:pic>
-    </p:spTree>
-  </p:cSld>
-  <p:clrMapOvr>
-    <a:masterClrMapping/>
-  </p:clrMapOvr>
-</p:sld>
-</file>
-
-<file path=ppt/slides/slide14.xml><?xml version="1.0" encoding="utf-8"?>
-<p:sld xmlns:a="http://schemas.openxmlformats.org/drawingml/2006/main" xmlns:p="http://schemas.openxmlformats.org/presentationml/2006/main" xmlns:r="http://schemas.openxmlformats.org/officeDocument/2006/relationships">
-  <p:cSld>
-    <p:spTree>
-      <p:nvGrpSpPr>
-        <p:cNvPr id="1" name=""/>
-        <p:cNvGrpSpPr/>
-        <p:nvPr/>
-      </p:nvGrpSpPr>
-      <p:grpSpPr/>
-      <p:pic>
-        <p:nvPicPr>
-          <p:cNvPr id="2" name="Picture 1" descr="14.png"/>
-          <p:cNvPicPr>
-            <a:picLocks noChangeAspect="1"/>
-          </p:cNvPicPr>
-          <p:nvPr/>
-        </p:nvPicPr>
-        <p:blipFill>
-          <a:blip r:embed="rId2"/>
-          <a:stretch>
-            <a:fillRect/>
-          </a:stretch>
-        </p:blipFill>
-        <p:spPr>
-          <a:xfrm>
-            <a:off x="0" y="0"/>
-            <a:ext cx="9144000" cy="5143500"/>
-          </a:xfrm>
-          <a:prstGeom prst="rect">
-            <a:avLst/>
-          </a:prstGeom>
-        </p:spPr>
-      </p:pic>
-    </p:spTree>
-  </p:cSld>
-  <p:clrMapOvr>
-    <a:masterClrMapping/>
-  </p:clrMapOvr>
-</p:sld>
-</file>
-
-<file path=ppt/slides/slide15.xml><?xml version="1.0" encoding="utf-8"?>
-<p:sld xmlns:a="http://schemas.openxmlformats.org/drawingml/2006/main" xmlns:p="http://schemas.openxmlformats.org/presentationml/2006/main" xmlns:r="http://schemas.openxmlformats.org/officeDocument/2006/relationships">
-  <p:cSld>
-    <p:spTree>
-      <p:nvGrpSpPr>
-        <p:cNvPr id="1" name=""/>
-        <p:cNvGrpSpPr/>
-        <p:nvPr/>
-      </p:nvGrpSpPr>
-      <p:grpSpPr/>
-      <p:pic>
-        <p:nvPicPr>
-          <p:cNvPr id="2" name="Picture 1" descr="15.png"/>
-          <p:cNvPicPr>
-            <a:picLocks noChangeAspect="1"/>
-          </p:cNvPicPr>
-          <p:nvPr/>
-        </p:nvPicPr>
-        <p:blipFill>
-          <a:blip r:embed="rId2"/>
-          <a:stretch>
-            <a:fillRect/>
-          </a:stretch>
-        </p:blipFill>
-        <p:spPr>
-          <a:xfrm>
-            <a:off x="0" y="0"/>
-            <a:ext cx="9144000" cy="5143500"/>
-          </a:xfrm>
-          <a:prstGeom prst="rect">
-            <a:avLst/>
-          </a:prstGeom>
-        </p:spPr>
-      </p:pic>
-    </p:spTree>
-  </p:cSld>
-  <p:clrMapOvr>
-    <a:masterClrMapping/>
-  </p:clrMapOvr>
-</p:sld>
-</file>
-
-<file path=ppt/slides/slide16.xml><?xml version="1.0" encoding="utf-8"?>
-<p:sld xmlns:a="http://schemas.openxmlformats.org/drawingml/2006/main" xmlns:p="http://schemas.openxmlformats.org/presentationml/2006/main" xmlns:r="http://schemas.openxmlformats.org/officeDocument/2006/relationships">
-  <p:cSld>
-    <p:spTree>
-      <p:nvGrpSpPr>
-        <p:cNvPr id="1" name=""/>
-        <p:cNvGrpSpPr/>
-        <p:nvPr/>
-      </p:nvGrpSpPr>
-      <p:grpSpPr/>
-      <p:pic>
-        <p:nvPicPr>
-          <p:cNvPr id="2" name="Picture 1" descr="16.png"/>
-          <p:cNvPicPr>
-            <a:picLocks noChangeAspect="1"/>
-          </p:cNvPicPr>
-          <p:nvPr/>
-        </p:nvPicPr>
-        <p:blipFill>
-          <a:blip r:embed="rId2"/>
-          <a:stretch>
-            <a:fillRect/>
-          </a:stretch>
-        </p:blipFill>
-        <p:spPr>
-          <a:xfrm>
-            <a:off x="0" y="0"/>
-            <a:ext cx="9144000" cy="5143500"/>
-          </a:xfrm>
-          <a:prstGeom prst="rect">
-            <a:avLst/>
-          </a:prstGeom>
-        </p:spPr>
-      </p:pic>
-    </p:spTree>
-  </p:cSld>
-  <p:clrMapOvr>
-    <a:masterClrMapping/>
-  </p:clrMapOvr>
-</p:sld>
-</file>
-
-<file path=ppt/slides/slide17.xml><?xml version="1.0" encoding="utf-8"?>
-<p:sld xmlns:a="http://schemas.openxmlformats.org/drawingml/2006/main" xmlns:p="http://schemas.openxmlformats.org/presentationml/2006/main" xmlns:r="http://schemas.openxmlformats.org/officeDocument/2006/relationships">
-  <p:cSld>
-    <p:spTree>
-      <p:nvGrpSpPr>
-        <p:cNvPr id="1" name=""/>
-        <p:cNvGrpSpPr/>
-        <p:nvPr/>
-      </p:nvGrpSpPr>
-      <p:grpSpPr/>
-      <p:pic>
-        <p:nvPicPr>
-          <p:cNvPr id="2" name="Picture 1" descr="17.png"/>
-          <p:cNvPicPr>
-            <a:picLocks noChangeAspect="1"/>
-          </p:cNvPicPr>
-          <p:nvPr/>
-        </p:nvPicPr>
-        <p:blipFill>
-          <a:blip r:embed="rId2"/>
-          <a:stretch>
-            <a:fillRect/>
-          </a:stretch>
-        </p:blipFill>
-        <p:spPr>
-          <a:xfrm>
-            <a:off x="0" y="0"/>
-            <a:ext cx="9144000" cy="5143500"/>
-          </a:xfrm>
-          <a:prstGeom prst="rect">
-            <a:avLst/>
-          </a:prstGeom>
-        </p:spPr>
-      </p:pic>
-    </p:spTree>
-  </p:cSld>
-  <p:clrMapOvr>
-    <a:masterClrMapping/>
-  </p:clrMapOvr>
-</p:sld>
-</file>
-
-<file path=ppt/slides/slide18.xml><?xml version="1.0" encoding="utf-8"?>
-<p:sld xmlns:a="http://schemas.openxmlformats.org/drawingml/2006/main" xmlns:p="http://schemas.openxmlformats.org/presentationml/2006/main" xmlns:r="http://schemas.openxmlformats.org/officeDocument/2006/relationships">
-  <p:cSld>
-    <p:spTree>
-      <p:nvGrpSpPr>
-        <p:cNvPr id="1" name=""/>
-        <p:cNvGrpSpPr/>
-        <p:nvPr/>
-      </p:nvGrpSpPr>
-      <p:grpSpPr/>
-      <p:pic>
-        <p:nvPicPr>
-          <p:cNvPr id="2" name="Picture 1" descr="18.png"/>
-          <p:cNvPicPr>
-            <a:picLocks noChangeAspect="1"/>
-          </p:cNvPicPr>
-          <p:nvPr/>
-        </p:nvPicPr>
-        <p:blipFill>
-          <a:blip r:embed="rId2"/>
-          <a:stretch>
-            <a:fillRect/>
-          </a:stretch>
-        </p:blipFill>
-        <p:spPr>
-          <a:xfrm>
-            <a:off x="0" y="0"/>
-            <a:ext cx="9144000" cy="5143500"/>
-          </a:xfrm>
-          <a:prstGeom prst="rect">
-            <a:avLst/>
-          </a:prstGeom>
-        </p:spPr>
-      </p:pic>
-    </p:spTree>
-  </p:cSld>
-  <p:clrMapOvr>
-    <a:masterClrMapping/>
-  </p:clrMapOvr>
-</p:sld>
-</file>
-
 <file path=ppt/slides/slide2.xml><?xml version="1.0" encoding="utf-8"?>
 <p:sld xmlns:a="http://schemas.openxmlformats.org/drawingml/2006/main" xmlns:p="http://schemas.openxmlformats.org/presentationml/2006/main" xmlns:r="http://schemas.openxmlformats.org/officeDocument/2006/relationships">
   <p:cSld>
@@ -3696,132 +3306,6 @@
       <p:pic>
         <p:nvPicPr>
           <p:cNvPr id="2" name="Picture 1" descr="06.png"/>
-          <p:cNvPicPr>
-            <a:picLocks noChangeAspect="1"/>
-          </p:cNvPicPr>
-          <p:nvPr/>
-        </p:nvPicPr>
-        <p:blipFill>
-          <a:blip r:embed="rId2"/>
-          <a:stretch>
-            <a:fillRect/>
-          </a:stretch>
-        </p:blipFill>
-        <p:spPr>
-          <a:xfrm>
-            <a:off x="0" y="0"/>
-            <a:ext cx="9144000" cy="5143500"/>
-          </a:xfrm>
-          <a:prstGeom prst="rect">
-            <a:avLst/>
-          </a:prstGeom>
-        </p:spPr>
-      </p:pic>
-    </p:spTree>
-  </p:cSld>
-  <p:clrMapOvr>
-    <a:masterClrMapping/>
-  </p:clrMapOvr>
-</p:sld>
-</file>
-
-<file path=ppt/slides/slide7.xml><?xml version="1.0" encoding="utf-8"?>
-<p:sld xmlns:a="http://schemas.openxmlformats.org/drawingml/2006/main" xmlns:p="http://schemas.openxmlformats.org/presentationml/2006/main" xmlns:r="http://schemas.openxmlformats.org/officeDocument/2006/relationships">
-  <p:cSld>
-    <p:spTree>
-      <p:nvGrpSpPr>
-        <p:cNvPr id="1" name=""/>
-        <p:cNvGrpSpPr/>
-        <p:nvPr/>
-      </p:nvGrpSpPr>
-      <p:grpSpPr/>
-      <p:pic>
-        <p:nvPicPr>
-          <p:cNvPr id="2" name="Picture 1" descr="07.png"/>
-          <p:cNvPicPr>
-            <a:picLocks noChangeAspect="1"/>
-          </p:cNvPicPr>
-          <p:nvPr/>
-        </p:nvPicPr>
-        <p:blipFill>
-          <a:blip r:embed="rId2"/>
-          <a:stretch>
-            <a:fillRect/>
-          </a:stretch>
-        </p:blipFill>
-        <p:spPr>
-          <a:xfrm>
-            <a:off x="0" y="0"/>
-            <a:ext cx="9144000" cy="5143500"/>
-          </a:xfrm>
-          <a:prstGeom prst="rect">
-            <a:avLst/>
-          </a:prstGeom>
-        </p:spPr>
-      </p:pic>
-    </p:spTree>
-  </p:cSld>
-  <p:clrMapOvr>
-    <a:masterClrMapping/>
-  </p:clrMapOvr>
-</p:sld>
-</file>
-
-<file path=ppt/slides/slide8.xml><?xml version="1.0" encoding="utf-8"?>
-<p:sld xmlns:a="http://schemas.openxmlformats.org/drawingml/2006/main" xmlns:p="http://schemas.openxmlformats.org/presentationml/2006/main" xmlns:r="http://schemas.openxmlformats.org/officeDocument/2006/relationships">
-  <p:cSld>
-    <p:spTree>
-      <p:nvGrpSpPr>
-        <p:cNvPr id="1" name=""/>
-        <p:cNvGrpSpPr/>
-        <p:nvPr/>
-      </p:nvGrpSpPr>
-      <p:grpSpPr/>
-      <p:pic>
-        <p:nvPicPr>
-          <p:cNvPr id="2" name="Picture 1" descr="08.png"/>
-          <p:cNvPicPr>
-            <a:picLocks noChangeAspect="1"/>
-          </p:cNvPicPr>
-          <p:nvPr/>
-        </p:nvPicPr>
-        <p:blipFill>
-          <a:blip r:embed="rId2"/>
-          <a:stretch>
-            <a:fillRect/>
-          </a:stretch>
-        </p:blipFill>
-        <p:spPr>
-          <a:xfrm>
-            <a:off x="0" y="0"/>
-            <a:ext cx="9144000" cy="5143500"/>
-          </a:xfrm>
-          <a:prstGeom prst="rect">
-            <a:avLst/>
-          </a:prstGeom>
-        </p:spPr>
-      </p:pic>
-    </p:spTree>
-  </p:cSld>
-  <p:clrMapOvr>
-    <a:masterClrMapping/>
-  </p:clrMapOvr>
-</p:sld>
-</file>
-
-<file path=ppt/slides/slide9.xml><?xml version="1.0" encoding="utf-8"?>
-<p:sld xmlns:a="http://schemas.openxmlformats.org/drawingml/2006/main" xmlns:p="http://schemas.openxmlformats.org/presentationml/2006/main" xmlns:r="http://schemas.openxmlformats.org/officeDocument/2006/relationships">
-  <p:cSld>
-    <p:spTree>
-      <p:nvGrpSpPr>
-        <p:cNvPr id="1" name=""/>
-        <p:cNvGrpSpPr/>
-        <p:nvPr/>
-      </p:nvGrpSpPr>
-      <p:grpSpPr/>
-      <p:pic>
-        <p:nvPicPr>
-          <p:cNvPr id="2" name="Picture 1" descr="09.png"/>
           <p:cNvPicPr>
             <a:picLocks noChangeAspect="1"/>
           </p:cNvPicPr>

</xml_diff>